<commit_message>
docs: deck DSI 2 slides + slide socle technique ouvert
Ajout d'une slide 2 dediee au socle technique (API ouverte, Docker,
Python/PostgreSQL, GitHub) avec la conclusion explicite : deplacable,
maintenable et repris par n'importe quelle equipe, sans verrou editeur.
Mention 'Python' ajoutee sur la slide 1 pour coherence.
</commit_message>
<xml_diff>
--- a/docs/demo-dsi-slide.pptx
+++ b/docs/demo-dsi-slide.pptx
@@ -6,6 +6,7 @@
   </p:sldMasterIdLst>
   <p:sldIdLst>
     <p:sldId id="256" r:id="rId7"/>
+    <p:sldId id="257" r:id="rId8"/>
   </p:sldIdLst>
   <p:sldSz cx="12192000" cy="6858000" type="screen4x3"/>
   <p:notesSz cx="6858000" cy="9144000"/>
@@ -3424,7 +3425,7 @@
                 </a:solidFill>
                 <a:latin typeface="Calibri"/>
               </a:rPr>
-              <a:t>Stack standard (FastAPI, PostgreSQL 16, React) — </a:t>
+              <a:t>Stack standard (Python/FastAPI, PostgreSQL 16, React) — </a:t>
             </a:r>
             <a:r>
               <a:rPr sz="1400" b="1">
@@ -4218,7 +4219,7 @@
         <p:spPr>
           <a:xfrm>
             <a:off x="685800" y="6300000"/>
-            <a:ext cx="9000000" cy="420000"/>
+            <a:ext cx="9200000" cy="420000"/>
           </a:xfrm>
           <a:prstGeom prst="rect">
             <a:avLst/>
@@ -4264,6 +4265,952 @@
       <p:sp>
         <p:nvSpPr>
           <p:cNvPr id="28" name="TextBox 27"/>
+          <p:cNvSpPr txBox="1"/>
+          <p:nvPr/>
+        </p:nvSpPr>
+        <p:spPr>
+          <a:xfrm>
+            <a:off x="9506200" y="6320000"/>
+            <a:ext cx="2000000" cy="360000"/>
+          </a:xfrm>
+          <a:prstGeom prst="rect">
+            <a:avLst/>
+          </a:prstGeom>
+          <a:noFill/>
+        </p:spPr>
+        <p:txBody>
+          <a:bodyPr wrap="square" anchor="t" lIns="0" rIns="0" tIns="0" bIns="0">
+            <a:spAutoFit/>
+          </a:bodyPr>
+          <a:lstStyle/>
+          <a:p>
+            <a:pPr algn="r"/>
+            <a:r>
+              <a:rPr sz="1300" b="1">
+                <a:solidFill>
+                  <a:srgbClr val="8A909A"/>
+                </a:solidFill>
+                <a:latin typeface="Calibri"/>
+              </a:rPr>
+              <a:t>OpsFlux</a:t>
+            </a:r>
+          </a:p>
+        </p:txBody>
+      </p:sp>
+    </p:spTree>
+  </p:cSld>
+  <p:clrMapOvr>
+    <a:masterClrMapping/>
+  </p:clrMapOvr>
+</p:sld>
+</file>
+
+<file path=ppt/slides/slide2.xml><?xml version="1.0" encoding="utf-8"?>
+<p:sld xmlns:a="http://schemas.openxmlformats.org/drawingml/2006/main" xmlns:p="http://schemas.openxmlformats.org/presentationml/2006/main" xmlns:r="http://schemas.openxmlformats.org/officeDocument/2006/relationships">
+  <p:cSld>
+    <p:spTree>
+      <p:nvGrpSpPr>
+        <p:cNvPr id="1" name=""/>
+        <p:cNvGrpSpPr/>
+        <p:nvPr/>
+      </p:nvGrpSpPr>
+      <p:grpSpPr/>
+      <p:sp>
+        <p:nvSpPr>
+          <p:cNvPr id="2" name="TextBox 1"/>
+          <p:cNvSpPr txBox="1"/>
+          <p:nvPr/>
+        </p:nvSpPr>
+        <p:spPr>
+          <a:xfrm>
+            <a:off x="685800" y="560000"/>
+            <a:ext cx="10820400" cy="300000"/>
+          </a:xfrm>
+          <a:prstGeom prst="rect">
+            <a:avLst/>
+          </a:prstGeom>
+          <a:noFill/>
+        </p:spPr>
+        <p:txBody>
+          <a:bodyPr wrap="square" anchor="t" lIns="0" rIns="0" tIns="0" bIns="0">
+            <a:spAutoFit/>
+          </a:bodyPr>
+          <a:lstStyle/>
+          <a:p>
+            <a:pPr algn="l"/>
+            <a:r>
+              <a:rPr sz="1100" b="1">
+                <a:solidFill>
+                  <a:srgbClr val="0A5C9C"/>
+                </a:solidFill>
+                <a:latin typeface="Calibri"/>
+              </a:rPr>
+              <a:t>ARCHITECTURE  ·  TECHNOLOGIES STANDARD DU MARCHÉ</a:t>
+            </a:r>
+          </a:p>
+        </p:txBody>
+      </p:sp>
+      <p:sp>
+        <p:nvSpPr>
+          <p:cNvPr id="3" name="TextBox 2"/>
+          <p:cNvSpPr txBox="1"/>
+          <p:nvPr/>
+        </p:nvSpPr>
+        <p:spPr>
+          <a:xfrm>
+            <a:off x="685800" y="820000"/>
+            <a:ext cx="10820400" cy="600000"/>
+          </a:xfrm>
+          <a:prstGeom prst="rect">
+            <a:avLst/>
+          </a:prstGeom>
+          <a:noFill/>
+        </p:spPr>
+        <p:txBody>
+          <a:bodyPr wrap="square" anchor="t" lIns="0" rIns="0" tIns="0" bIns="0">
+            <a:spAutoFit/>
+          </a:bodyPr>
+          <a:lstStyle/>
+          <a:p>
+            <a:pPr algn="l"/>
+            <a:r>
+              <a:rPr sz="3200" b="1">
+                <a:solidFill>
+                  <a:srgbClr val="1A1D23"/>
+                </a:solidFill>
+                <a:latin typeface="Calibri"/>
+              </a:rPr>
+              <a:t>Un socle ouvert, déplaçable et maintenable</a:t>
+            </a:r>
+          </a:p>
+        </p:txBody>
+      </p:sp>
+      <p:sp>
+        <p:nvSpPr>
+          <p:cNvPr id="4" name="TextBox 3"/>
+          <p:cNvSpPr txBox="1"/>
+          <p:nvPr/>
+        </p:nvSpPr>
+        <p:spPr>
+          <a:xfrm>
+            <a:off x="685800" y="1430000"/>
+            <a:ext cx="10820400" cy="360000"/>
+          </a:xfrm>
+          <a:prstGeom prst="rect">
+            <a:avLst/>
+          </a:prstGeom>
+          <a:noFill/>
+        </p:spPr>
+        <p:txBody>
+          <a:bodyPr wrap="square" anchor="t" lIns="0" rIns="0" tIns="0" bIns="0">
+            <a:spAutoFit/>
+          </a:bodyPr>
+          <a:lstStyle/>
+          <a:p>
+            <a:pPr algn="l"/>
+            <a:r>
+              <a:rPr sz="1500" b="0">
+                <a:solidFill>
+                  <a:srgbClr val="5C636E"/>
+                </a:solidFill>
+                <a:latin typeface="Calibri"/>
+              </a:rPr>
+              <a:t>Aucune technologie propriétaire — aucun verrou éditeur</a:t>
+            </a:r>
+          </a:p>
+        </p:txBody>
+      </p:sp>
+      <p:sp>
+        <p:nvSpPr>
+          <p:cNvPr id="5" name="Rectangle 4"/>
+          <p:cNvSpPr/>
+          <p:nvPr/>
+        </p:nvSpPr>
+        <p:spPr>
+          <a:xfrm>
+            <a:off x="685800" y="1870000"/>
+            <a:ext cx="560000" cy="38100"/>
+          </a:xfrm>
+          <a:prstGeom prst="rect">
+            <a:avLst/>
+          </a:prstGeom>
+          <a:solidFill>
+            <a:srgbClr val="0A5C9C"/>
+          </a:solidFill>
+          <a:ln>
+            <a:noFill/>
+          </a:ln>
+          <a:effectLst/>
+        </p:spPr>
+        <p:style>
+          <a:lnRef idx="1">
+            <a:schemeClr val="accent1"/>
+          </a:lnRef>
+          <a:fillRef idx="3">
+            <a:schemeClr val="accent1"/>
+          </a:fillRef>
+          <a:effectRef idx="2">
+            <a:schemeClr val="accent1"/>
+          </a:effectRef>
+          <a:fontRef idx="minor">
+            <a:schemeClr val="lt1"/>
+          </a:fontRef>
+        </p:style>
+        <p:txBody>
+          <a:bodyPr rtlCol="0" anchor="ctr"/>
+          <a:lstStyle/>
+          <a:p>
+            <a:pPr algn="ctr"/>
+          </a:p>
+        </p:txBody>
+      </p:sp>
+      <p:sp>
+        <p:nvSpPr>
+          <p:cNvPr id="6" name="Rectangle 5"/>
+          <p:cNvSpPr/>
+          <p:nvPr/>
+        </p:nvSpPr>
+        <p:spPr>
+          <a:xfrm>
+            <a:off x="685800" y="2200000"/>
+            <a:ext cx="5270200" cy="1380000"/>
+          </a:xfrm>
+          <a:prstGeom prst="rect">
+            <a:avLst/>
+          </a:prstGeom>
+          <a:solidFill>
+            <a:srgbClr val="EDF3F9"/>
+          </a:solidFill>
+          <a:ln>
+            <a:noFill/>
+          </a:ln>
+          <a:effectLst/>
+        </p:spPr>
+        <p:style>
+          <a:lnRef idx="1">
+            <a:schemeClr val="accent1"/>
+          </a:lnRef>
+          <a:fillRef idx="3">
+            <a:schemeClr val="accent1"/>
+          </a:fillRef>
+          <a:effectRef idx="2">
+            <a:schemeClr val="accent1"/>
+          </a:effectRef>
+          <a:fontRef idx="minor">
+            <a:schemeClr val="lt1"/>
+          </a:fontRef>
+        </p:style>
+        <p:txBody>
+          <a:bodyPr rtlCol="0" anchor="ctr"/>
+          <a:lstStyle/>
+          <a:p>
+            <a:pPr algn="ctr"/>
+          </a:p>
+        </p:txBody>
+      </p:sp>
+      <p:sp>
+        <p:nvSpPr>
+          <p:cNvPr id="7" name="Rectangle 6"/>
+          <p:cNvSpPr/>
+          <p:nvPr/>
+        </p:nvSpPr>
+        <p:spPr>
+          <a:xfrm>
+            <a:off x="685800" y="2200000"/>
+            <a:ext cx="50800" cy="1380000"/>
+          </a:xfrm>
+          <a:prstGeom prst="rect">
+            <a:avLst/>
+          </a:prstGeom>
+          <a:solidFill>
+            <a:srgbClr val="0A5C9C"/>
+          </a:solidFill>
+          <a:ln>
+            <a:noFill/>
+          </a:ln>
+          <a:effectLst/>
+        </p:spPr>
+        <p:style>
+          <a:lnRef idx="1">
+            <a:schemeClr val="accent1"/>
+          </a:lnRef>
+          <a:fillRef idx="3">
+            <a:schemeClr val="accent1"/>
+          </a:fillRef>
+          <a:effectRef idx="2">
+            <a:schemeClr val="accent1"/>
+          </a:effectRef>
+          <a:fontRef idx="minor">
+            <a:schemeClr val="lt1"/>
+          </a:fontRef>
+        </p:style>
+        <p:txBody>
+          <a:bodyPr rtlCol="0" anchor="ctr"/>
+          <a:lstStyle/>
+          <a:p>
+            <a:pPr algn="ctr"/>
+          </a:p>
+        </p:txBody>
+      </p:sp>
+      <p:sp>
+        <p:nvSpPr>
+          <p:cNvPr id="8" name="TextBox 7"/>
+          <p:cNvSpPr txBox="1"/>
+          <p:nvPr/>
+        </p:nvSpPr>
+        <p:spPr>
+          <a:xfrm>
+            <a:off x="925800" y="2360000"/>
+            <a:ext cx="4790200" cy="320000"/>
+          </a:xfrm>
+          <a:prstGeom prst="rect">
+            <a:avLst/>
+          </a:prstGeom>
+          <a:noFill/>
+        </p:spPr>
+        <p:txBody>
+          <a:bodyPr wrap="square" anchor="t" lIns="0" rIns="0" tIns="0" bIns="0">
+            <a:spAutoFit/>
+          </a:bodyPr>
+          <a:lstStyle/>
+          <a:p>
+            <a:pPr algn="l"/>
+            <a:r>
+              <a:rPr sz="1700" b="1">
+                <a:solidFill>
+                  <a:srgbClr val="1A1D23"/>
+                </a:solidFill>
+                <a:latin typeface="Calibri"/>
+              </a:rPr>
+              <a:t>API ouverte</a:t>
+            </a:r>
+          </a:p>
+        </p:txBody>
+      </p:sp>
+      <p:sp>
+        <p:nvSpPr>
+          <p:cNvPr id="9" name="TextBox 8"/>
+          <p:cNvSpPr txBox="1"/>
+          <p:nvPr/>
+        </p:nvSpPr>
+        <p:spPr>
+          <a:xfrm>
+            <a:off x="925800" y="2760000"/>
+            <a:ext cx="4790200" cy="760000"/>
+          </a:xfrm>
+          <a:prstGeom prst="rect">
+            <a:avLst/>
+          </a:prstGeom>
+          <a:noFill/>
+        </p:spPr>
+        <p:txBody>
+          <a:bodyPr wrap="square" anchor="t" lIns="0" rIns="0" tIns="0" bIns="0">
+            <a:spAutoFit/>
+          </a:bodyPr>
+          <a:lstStyle/>
+          <a:p>
+            <a:pPr algn="l">
+              <a:lnSpc>
+                <a:spcPct val="112000"/>
+              </a:lnSpc>
+            </a:pPr>
+            <a:r>
+              <a:rPr sz="1300" b="0">
+                <a:solidFill>
+                  <a:srgbClr val="5C636E"/>
+                </a:solidFill>
+                <a:latin typeface="Calibri"/>
+              </a:rPr>
+              <a:t>REST documentée (OpenAPI / Swagger). Tout ce que fait l'interface est disponible en API — intégrable aux outils du Groupe.</a:t>
+            </a:r>
+          </a:p>
+        </p:txBody>
+      </p:sp>
+      <p:sp>
+        <p:nvSpPr>
+          <p:cNvPr id="10" name="Rectangle 9"/>
+          <p:cNvSpPr/>
+          <p:nvPr/>
+        </p:nvSpPr>
+        <p:spPr>
+          <a:xfrm>
+            <a:off x="6236000" y="2200000"/>
+            <a:ext cx="5270200" cy="1380000"/>
+          </a:xfrm>
+          <a:prstGeom prst="rect">
+            <a:avLst/>
+          </a:prstGeom>
+          <a:solidFill>
+            <a:srgbClr val="EDF3F9"/>
+          </a:solidFill>
+          <a:ln>
+            <a:noFill/>
+          </a:ln>
+          <a:effectLst/>
+        </p:spPr>
+        <p:style>
+          <a:lnRef idx="1">
+            <a:schemeClr val="accent1"/>
+          </a:lnRef>
+          <a:fillRef idx="3">
+            <a:schemeClr val="accent1"/>
+          </a:fillRef>
+          <a:effectRef idx="2">
+            <a:schemeClr val="accent1"/>
+          </a:effectRef>
+          <a:fontRef idx="minor">
+            <a:schemeClr val="lt1"/>
+          </a:fontRef>
+        </p:style>
+        <p:txBody>
+          <a:bodyPr rtlCol="0" anchor="ctr"/>
+          <a:lstStyle/>
+          <a:p>
+            <a:pPr algn="ctr"/>
+          </a:p>
+        </p:txBody>
+      </p:sp>
+      <p:sp>
+        <p:nvSpPr>
+          <p:cNvPr id="11" name="Rectangle 10"/>
+          <p:cNvSpPr/>
+          <p:nvPr/>
+        </p:nvSpPr>
+        <p:spPr>
+          <a:xfrm>
+            <a:off x="6236000" y="2200000"/>
+            <a:ext cx="50800" cy="1380000"/>
+          </a:xfrm>
+          <a:prstGeom prst="rect">
+            <a:avLst/>
+          </a:prstGeom>
+          <a:solidFill>
+            <a:srgbClr val="0A5C9C"/>
+          </a:solidFill>
+          <a:ln>
+            <a:noFill/>
+          </a:ln>
+          <a:effectLst/>
+        </p:spPr>
+        <p:style>
+          <a:lnRef idx="1">
+            <a:schemeClr val="accent1"/>
+          </a:lnRef>
+          <a:fillRef idx="3">
+            <a:schemeClr val="accent1"/>
+          </a:fillRef>
+          <a:effectRef idx="2">
+            <a:schemeClr val="accent1"/>
+          </a:effectRef>
+          <a:fontRef idx="minor">
+            <a:schemeClr val="lt1"/>
+          </a:fontRef>
+        </p:style>
+        <p:txBody>
+          <a:bodyPr rtlCol="0" anchor="ctr"/>
+          <a:lstStyle/>
+          <a:p>
+            <a:pPr algn="ctr"/>
+          </a:p>
+        </p:txBody>
+      </p:sp>
+      <p:sp>
+        <p:nvSpPr>
+          <p:cNvPr id="12" name="TextBox 11"/>
+          <p:cNvSpPr txBox="1"/>
+          <p:nvPr/>
+        </p:nvSpPr>
+        <p:spPr>
+          <a:xfrm>
+            <a:off x="6476000" y="2360000"/>
+            <a:ext cx="4790200" cy="320000"/>
+          </a:xfrm>
+          <a:prstGeom prst="rect">
+            <a:avLst/>
+          </a:prstGeom>
+          <a:noFill/>
+        </p:spPr>
+        <p:txBody>
+          <a:bodyPr wrap="square" anchor="t" lIns="0" rIns="0" tIns="0" bIns="0">
+            <a:spAutoFit/>
+          </a:bodyPr>
+          <a:lstStyle/>
+          <a:p>
+            <a:pPr algn="l"/>
+            <a:r>
+              <a:rPr sz="1700" b="1">
+                <a:solidFill>
+                  <a:srgbClr val="1A1D23"/>
+                </a:solidFill>
+                <a:latin typeface="Calibri"/>
+              </a:rPr>
+              <a:t>Docker</a:t>
+            </a:r>
+          </a:p>
+        </p:txBody>
+      </p:sp>
+      <p:sp>
+        <p:nvSpPr>
+          <p:cNvPr id="13" name="TextBox 12"/>
+          <p:cNvSpPr txBox="1"/>
+          <p:nvPr/>
+        </p:nvSpPr>
+        <p:spPr>
+          <a:xfrm>
+            <a:off x="6476000" y="2760000"/>
+            <a:ext cx="4790200" cy="760000"/>
+          </a:xfrm>
+          <a:prstGeom prst="rect">
+            <a:avLst/>
+          </a:prstGeom>
+          <a:noFill/>
+        </p:spPr>
+        <p:txBody>
+          <a:bodyPr wrap="square" anchor="t" lIns="0" rIns="0" tIns="0" bIns="0">
+            <a:spAutoFit/>
+          </a:bodyPr>
+          <a:lstStyle/>
+          <a:p>
+            <a:pPr algn="l">
+              <a:lnSpc>
+                <a:spcPct val="112000"/>
+              </a:lnSpc>
+            </a:pPr>
+            <a:r>
+              <a:rPr sz="1300" b="0">
+                <a:solidFill>
+                  <a:srgbClr val="5C636E"/>
+                </a:solidFill>
+                <a:latin typeface="Calibri"/>
+              </a:rPr>
+              <a:t>Conteneurisé : déployable sur votre infrastructure, votre cloud souverain ou on-premise. On l'installe où vous voulez.</a:t>
+            </a:r>
+          </a:p>
+        </p:txBody>
+      </p:sp>
+      <p:sp>
+        <p:nvSpPr>
+          <p:cNvPr id="14" name="Rectangle 13"/>
+          <p:cNvSpPr/>
+          <p:nvPr/>
+        </p:nvSpPr>
+        <p:spPr>
+          <a:xfrm>
+            <a:off x="685800" y="3860000"/>
+            <a:ext cx="5270200" cy="1380000"/>
+          </a:xfrm>
+          <a:prstGeom prst="rect">
+            <a:avLst/>
+          </a:prstGeom>
+          <a:solidFill>
+            <a:srgbClr val="EDF3F9"/>
+          </a:solidFill>
+          <a:ln>
+            <a:noFill/>
+          </a:ln>
+          <a:effectLst/>
+        </p:spPr>
+        <p:style>
+          <a:lnRef idx="1">
+            <a:schemeClr val="accent1"/>
+          </a:lnRef>
+          <a:fillRef idx="3">
+            <a:schemeClr val="accent1"/>
+          </a:fillRef>
+          <a:effectRef idx="2">
+            <a:schemeClr val="accent1"/>
+          </a:effectRef>
+          <a:fontRef idx="minor">
+            <a:schemeClr val="lt1"/>
+          </a:fontRef>
+        </p:style>
+        <p:txBody>
+          <a:bodyPr rtlCol="0" anchor="ctr"/>
+          <a:lstStyle/>
+          <a:p>
+            <a:pPr algn="ctr"/>
+          </a:p>
+        </p:txBody>
+      </p:sp>
+      <p:sp>
+        <p:nvSpPr>
+          <p:cNvPr id="15" name="Rectangle 14"/>
+          <p:cNvSpPr/>
+          <p:nvPr/>
+        </p:nvSpPr>
+        <p:spPr>
+          <a:xfrm>
+            <a:off x="685800" y="3860000"/>
+            <a:ext cx="50800" cy="1380000"/>
+          </a:xfrm>
+          <a:prstGeom prst="rect">
+            <a:avLst/>
+          </a:prstGeom>
+          <a:solidFill>
+            <a:srgbClr val="0A5C9C"/>
+          </a:solidFill>
+          <a:ln>
+            <a:noFill/>
+          </a:ln>
+          <a:effectLst/>
+        </p:spPr>
+        <p:style>
+          <a:lnRef idx="1">
+            <a:schemeClr val="accent1"/>
+          </a:lnRef>
+          <a:fillRef idx="3">
+            <a:schemeClr val="accent1"/>
+          </a:fillRef>
+          <a:effectRef idx="2">
+            <a:schemeClr val="accent1"/>
+          </a:effectRef>
+          <a:fontRef idx="minor">
+            <a:schemeClr val="lt1"/>
+          </a:fontRef>
+        </p:style>
+        <p:txBody>
+          <a:bodyPr rtlCol="0" anchor="ctr"/>
+          <a:lstStyle/>
+          <a:p>
+            <a:pPr algn="ctr"/>
+          </a:p>
+        </p:txBody>
+      </p:sp>
+      <p:sp>
+        <p:nvSpPr>
+          <p:cNvPr id="16" name="TextBox 15"/>
+          <p:cNvSpPr txBox="1"/>
+          <p:nvPr/>
+        </p:nvSpPr>
+        <p:spPr>
+          <a:xfrm>
+            <a:off x="925800" y="4020000"/>
+            <a:ext cx="4790200" cy="320000"/>
+          </a:xfrm>
+          <a:prstGeom prst="rect">
+            <a:avLst/>
+          </a:prstGeom>
+          <a:noFill/>
+        </p:spPr>
+        <p:txBody>
+          <a:bodyPr wrap="square" anchor="t" lIns="0" rIns="0" tIns="0" bIns="0">
+            <a:spAutoFit/>
+          </a:bodyPr>
+          <a:lstStyle/>
+          <a:p>
+            <a:pPr algn="l"/>
+            <a:r>
+              <a:rPr sz="1700" b="1">
+                <a:solidFill>
+                  <a:srgbClr val="1A1D23"/>
+                </a:solidFill>
+                <a:latin typeface="Calibri"/>
+              </a:rPr>
+              <a:t>Python + PostgreSQL</a:t>
+            </a:r>
+          </a:p>
+        </p:txBody>
+      </p:sp>
+      <p:sp>
+        <p:nvSpPr>
+          <p:cNvPr id="17" name="TextBox 16"/>
+          <p:cNvSpPr txBox="1"/>
+          <p:nvPr/>
+        </p:nvSpPr>
+        <p:spPr>
+          <a:xfrm>
+            <a:off x="925800" y="4420000"/>
+            <a:ext cx="4790200" cy="760000"/>
+          </a:xfrm>
+          <a:prstGeom prst="rect">
+            <a:avLst/>
+          </a:prstGeom>
+          <a:noFill/>
+        </p:spPr>
+        <p:txBody>
+          <a:bodyPr wrap="square" anchor="t" lIns="0" rIns="0" tIns="0" bIns="0">
+            <a:spAutoFit/>
+          </a:bodyPr>
+          <a:lstStyle/>
+          <a:p>
+            <a:pPr algn="l">
+              <a:lnSpc>
+                <a:spcPct val="112000"/>
+              </a:lnSpc>
+            </a:pPr>
+            <a:r>
+              <a:rPr sz="1300" b="0">
+                <a:solidFill>
+                  <a:srgbClr val="5C636E"/>
+                </a:solidFill>
+                <a:latin typeface="Calibri"/>
+              </a:rPr>
+              <a:t>FastAPI (Python) et PostgreSQL 16 : technologies parmi les plus répandues — compétences disponibles partout.</a:t>
+            </a:r>
+          </a:p>
+        </p:txBody>
+      </p:sp>
+      <p:sp>
+        <p:nvSpPr>
+          <p:cNvPr id="18" name="Rectangle 17"/>
+          <p:cNvSpPr/>
+          <p:nvPr/>
+        </p:nvSpPr>
+        <p:spPr>
+          <a:xfrm>
+            <a:off x="6236000" y="3860000"/>
+            <a:ext cx="5270200" cy="1380000"/>
+          </a:xfrm>
+          <a:prstGeom prst="rect">
+            <a:avLst/>
+          </a:prstGeom>
+          <a:solidFill>
+            <a:srgbClr val="EDF3F9"/>
+          </a:solidFill>
+          <a:ln>
+            <a:noFill/>
+          </a:ln>
+          <a:effectLst/>
+        </p:spPr>
+        <p:style>
+          <a:lnRef idx="1">
+            <a:schemeClr val="accent1"/>
+          </a:lnRef>
+          <a:fillRef idx="3">
+            <a:schemeClr val="accent1"/>
+          </a:fillRef>
+          <a:effectRef idx="2">
+            <a:schemeClr val="accent1"/>
+          </a:effectRef>
+          <a:fontRef idx="minor">
+            <a:schemeClr val="lt1"/>
+          </a:fontRef>
+        </p:style>
+        <p:txBody>
+          <a:bodyPr rtlCol="0" anchor="ctr"/>
+          <a:lstStyle/>
+          <a:p>
+            <a:pPr algn="ctr"/>
+          </a:p>
+        </p:txBody>
+      </p:sp>
+      <p:sp>
+        <p:nvSpPr>
+          <p:cNvPr id="19" name="Rectangle 18"/>
+          <p:cNvSpPr/>
+          <p:nvPr/>
+        </p:nvSpPr>
+        <p:spPr>
+          <a:xfrm>
+            <a:off x="6236000" y="3860000"/>
+            <a:ext cx="50800" cy="1380000"/>
+          </a:xfrm>
+          <a:prstGeom prst="rect">
+            <a:avLst/>
+          </a:prstGeom>
+          <a:solidFill>
+            <a:srgbClr val="0A5C9C"/>
+          </a:solidFill>
+          <a:ln>
+            <a:noFill/>
+          </a:ln>
+          <a:effectLst/>
+        </p:spPr>
+        <p:style>
+          <a:lnRef idx="1">
+            <a:schemeClr val="accent1"/>
+          </a:lnRef>
+          <a:fillRef idx="3">
+            <a:schemeClr val="accent1"/>
+          </a:fillRef>
+          <a:effectRef idx="2">
+            <a:schemeClr val="accent1"/>
+          </a:effectRef>
+          <a:fontRef idx="minor">
+            <a:schemeClr val="lt1"/>
+          </a:fontRef>
+        </p:style>
+        <p:txBody>
+          <a:bodyPr rtlCol="0" anchor="ctr"/>
+          <a:lstStyle/>
+          <a:p>
+            <a:pPr algn="ctr"/>
+          </a:p>
+        </p:txBody>
+      </p:sp>
+      <p:sp>
+        <p:nvSpPr>
+          <p:cNvPr id="20" name="TextBox 19"/>
+          <p:cNvSpPr txBox="1"/>
+          <p:nvPr/>
+        </p:nvSpPr>
+        <p:spPr>
+          <a:xfrm>
+            <a:off x="6476000" y="4020000"/>
+            <a:ext cx="4790200" cy="320000"/>
+          </a:xfrm>
+          <a:prstGeom prst="rect">
+            <a:avLst/>
+          </a:prstGeom>
+          <a:noFill/>
+        </p:spPr>
+        <p:txBody>
+          <a:bodyPr wrap="square" anchor="t" lIns="0" rIns="0" tIns="0" bIns="0">
+            <a:spAutoFit/>
+          </a:bodyPr>
+          <a:lstStyle/>
+          <a:p>
+            <a:pPr algn="l"/>
+            <a:r>
+              <a:rPr sz="1700" b="1">
+                <a:solidFill>
+                  <a:srgbClr val="1A1D23"/>
+                </a:solidFill>
+                <a:latin typeface="Calibri"/>
+              </a:rPr>
+              <a:t>GitHub</a:t>
+            </a:r>
+          </a:p>
+        </p:txBody>
+      </p:sp>
+      <p:sp>
+        <p:nvSpPr>
+          <p:cNvPr id="21" name="TextBox 20"/>
+          <p:cNvSpPr txBox="1"/>
+          <p:nvPr/>
+        </p:nvSpPr>
+        <p:spPr>
+          <a:xfrm>
+            <a:off x="6476000" y="4420000"/>
+            <a:ext cx="4790200" cy="760000"/>
+          </a:xfrm>
+          <a:prstGeom prst="rect">
+            <a:avLst/>
+          </a:prstGeom>
+          <a:noFill/>
+        </p:spPr>
+        <p:txBody>
+          <a:bodyPr wrap="square" anchor="t" lIns="0" rIns="0" tIns="0" bIns="0">
+            <a:spAutoFit/>
+          </a:bodyPr>
+          <a:lstStyle/>
+          <a:p>
+            <a:pPr algn="l">
+              <a:lnSpc>
+                <a:spcPct val="112000"/>
+              </a:lnSpc>
+            </a:pPr>
+            <a:r>
+              <a:rPr sz="1300" b="0">
+                <a:solidFill>
+                  <a:srgbClr val="5C636E"/>
+                </a:solidFill>
+                <a:latin typeface="Calibri"/>
+              </a:rPr>
+              <a:t>Code versionné, documenté, historisé. Repris par tout prestataire ou équipe interne, sans le développeur d'origine.</a:t>
+            </a:r>
+          </a:p>
+        </p:txBody>
+      </p:sp>
+      <p:sp>
+        <p:nvSpPr>
+          <p:cNvPr id="22" name="Rectangle 21"/>
+          <p:cNvSpPr/>
+          <p:nvPr/>
+        </p:nvSpPr>
+        <p:spPr>
+          <a:xfrm>
+            <a:off x="685800" y="6180000"/>
+            <a:ext cx="10820400" cy="25400"/>
+          </a:xfrm>
+          <a:prstGeom prst="rect">
+            <a:avLst/>
+          </a:prstGeom>
+          <a:solidFill>
+            <a:srgbClr val="1A1D23"/>
+          </a:solidFill>
+          <a:ln>
+            <a:noFill/>
+          </a:ln>
+          <a:effectLst/>
+        </p:spPr>
+        <p:style>
+          <a:lnRef idx="1">
+            <a:schemeClr val="accent1"/>
+          </a:lnRef>
+          <a:fillRef idx="3">
+            <a:schemeClr val="accent1"/>
+          </a:fillRef>
+          <a:effectRef idx="2">
+            <a:schemeClr val="accent1"/>
+          </a:effectRef>
+          <a:fontRef idx="minor">
+            <a:schemeClr val="lt1"/>
+          </a:fontRef>
+        </p:style>
+        <p:txBody>
+          <a:bodyPr rtlCol="0" anchor="ctr"/>
+          <a:lstStyle/>
+          <a:p>
+            <a:pPr algn="ctr"/>
+          </a:p>
+        </p:txBody>
+      </p:sp>
+      <p:sp>
+        <p:nvSpPr>
+          <p:cNvPr id="23" name="TextBox 22"/>
+          <p:cNvSpPr txBox="1"/>
+          <p:nvPr/>
+        </p:nvSpPr>
+        <p:spPr>
+          <a:xfrm>
+            <a:off x="685800" y="6300000"/>
+            <a:ext cx="9200000" cy="420000"/>
+          </a:xfrm>
+          <a:prstGeom prst="rect">
+            <a:avLst/>
+          </a:prstGeom>
+          <a:noFill/>
+        </p:spPr>
+        <p:txBody>
+          <a:bodyPr wrap="square" lIns="0" rIns="0" tIns="0" bIns="0">
+            <a:spAutoFit/>
+          </a:bodyPr>
+          <a:lstStyle/>
+          <a:p>
+            <a:r>
+              <a:rPr sz="1600" b="1">
+                <a:solidFill>
+                  <a:srgbClr val="1A1D23"/>
+                </a:solidFill>
+                <a:latin typeface="Calibri"/>
+              </a:rPr>
+              <a:t>Technos standards → </a:t>
+            </a:r>
+            <a:r>
+              <a:rPr sz="1600" b="1">
+                <a:solidFill>
+                  <a:srgbClr val="0A5C9C"/>
+                </a:solidFill>
+                <a:latin typeface="Calibri"/>
+              </a:rPr>
+              <a:t>déplaçable, maintenable et repris par n'importe quelle équipe</a:t>
+            </a:r>
+            <a:r>
+              <a:rPr sz="1600" b="1">
+                <a:solidFill>
+                  <a:srgbClr val="1A1D23"/>
+                </a:solidFill>
+                <a:latin typeface="Calibri"/>
+              </a:rPr>
+              <a:t>.</a:t>
+            </a:r>
+          </a:p>
+        </p:txBody>
+      </p:sp>
+      <p:sp>
+        <p:nvSpPr>
+          <p:cNvPr id="24" name="TextBox 23"/>
           <p:cNvSpPr txBox="1"/>
           <p:nvPr/>
         </p:nvSpPr>

</xml_diff>